<commit_message>
docs: update ReSet_Presentation.pptx with latest changes
</commit_message>
<xml_diff>
--- a/docs/ReSet_Presentation.pptx
+++ b/docs/ReSet_Presentation.pptx
@@ -6081,7 +6081,56 @@
             </a:r>
             <a:endParaRPr sz="1150">
               <a:solidFill>
-                <a:schemeClr val="dk1"/>
+                <a:srgbClr val="1E293B"/>
+              </a:solidFill>
+              <a:latin typeface="Calibri"/>
+              <a:ea typeface="Calibri"/>
+              <a:cs typeface="Calibri"/>
+              <a:sym typeface="Calibri"/>
+            </a:endParaRPr>
+          </a:p>
+          <a:p>
+            <a:pPr indent="-182563" lvl="0" marL="182563" marR="0" rtl="0" algn="l">
+              <a:spcBef>
+                <a:spcPts val="1200"/>
+              </a:spcBef>
+              <a:spcAft>
+                <a:spcPts val="0"/>
+              </a:spcAft>
+              <a:buClr>
+                <a:srgbClr val="1E293B"/>
+              </a:buClr>
+              <a:buSzPts val="1150"/>
+              <a:buFont typeface="Calibri"/>
+              <a:buChar char="✔"/>
+            </a:pPr>
+            <a:r>
+              <a:rPr lang="en-US" sz="1150">
+                <a:solidFill>
+                  <a:srgbClr val="1E293B"/>
+                </a:solidFill>
+                <a:latin typeface="Calibri"/>
+                <a:ea typeface="Calibri"/>
+                <a:cs typeface="Calibri"/>
+                <a:sym typeface="Calibri"/>
+              </a:rPr>
+              <a:t>T-SQL AST </a:t>
+            </a:r>
+            <a:r>
+              <a:rPr lang="en-US" sz="1150">
+                <a:solidFill>
+                  <a:srgbClr val="1E293B"/>
+                </a:solidFill>
+                <a:latin typeface="Calibri"/>
+                <a:ea typeface="Calibri"/>
+                <a:cs typeface="Calibri"/>
+                <a:sym typeface="Calibri"/>
+              </a:rPr>
+              <a:t>기반 정적 분석 (ScriptDom)</a:t>
+            </a:r>
+            <a:endParaRPr sz="1150">
+              <a:solidFill>
+                <a:srgbClr val="1E293B"/>
               </a:solidFill>
               <a:latin typeface="Calibri"/>
               <a:ea typeface="Calibri"/>
@@ -13397,6 +13446,285 @@
 </file>
 
 <file path=ppt/theme/theme1.xml><?xml version="1.0" encoding="utf-8"?>
+<a:theme xmlns:a="http://schemas.openxmlformats.org/drawingml/2006/main" xmlns:r="http://schemas.openxmlformats.org/officeDocument/2006/relationships" name="Office Theme">
+  <a:themeElements>
+    <a:clrScheme name="Office">
+      <a:dk1>
+        <a:srgbClr val="000000"/>
+      </a:dk1>
+      <a:lt1>
+        <a:srgbClr val="FFFFFF"/>
+      </a:lt1>
+      <a:dk2>
+        <a:srgbClr val="44546A"/>
+      </a:dk2>
+      <a:lt2>
+        <a:srgbClr val="E7E6E6"/>
+      </a:lt2>
+      <a:accent1>
+        <a:srgbClr val="4472C4"/>
+      </a:accent1>
+      <a:accent2>
+        <a:srgbClr val="ED7D31"/>
+      </a:accent2>
+      <a:accent3>
+        <a:srgbClr val="A5A5A5"/>
+      </a:accent3>
+      <a:accent4>
+        <a:srgbClr val="FFC000"/>
+      </a:accent4>
+      <a:accent5>
+        <a:srgbClr val="5B9BD5"/>
+      </a:accent5>
+      <a:accent6>
+        <a:srgbClr val="70AD47"/>
+      </a:accent6>
+      <a:hlink>
+        <a:srgbClr val="0563C1"/>
+      </a:hlink>
+      <a:folHlink>
+        <a:srgbClr val="954F72"/>
+      </a:folHlink>
+    </a:clrScheme>
+    <a:fontScheme name="Office">
+      <a:majorFont>
+        <a:latin typeface="Arial"/>
+        <a:ea typeface=""/>
+        <a:cs typeface=""/>
+        <a:font script="Jpan" typeface="ＭＳ Ｐゴシック"/>
+        <a:font script="Hang" typeface="맑은 고딕"/>
+        <a:font script="Hans" typeface="宋体"/>
+        <a:font script="Hant" typeface="新細明體"/>
+        <a:font script="Arab" typeface="Times New Roman"/>
+        <a:font script="Hebr" typeface="Times New Roman"/>
+        <a:font script="Thai" typeface="Angsana New"/>
+        <a:font script="Ethi" typeface="Nyala"/>
+        <a:font script="Beng" typeface="Vrinda"/>
+        <a:font script="Gujr" typeface="Shruti"/>
+        <a:font script="Khmr" typeface="MoolBoran"/>
+        <a:font script="Knda" typeface="Tunga"/>
+        <a:font script="Guru" typeface="Raavi"/>
+        <a:font script="Cans" typeface="Euphemia"/>
+        <a:font script="Cher" typeface="Plantagenet Cherokee"/>
+        <a:font script="Yiii" typeface="Microsoft Yi Baiti"/>
+        <a:font script="Tibt" typeface="Microsoft Himalaya"/>
+        <a:font script="Thaa" typeface="MV Boli"/>
+        <a:font script="Deva" typeface="Mangal"/>
+        <a:font script="Telu" typeface="Gautami"/>
+        <a:font script="Taml" typeface="Latha"/>
+        <a:font script="Syrc" typeface="Estrangelo Edessa"/>
+        <a:font script="Orya" typeface="Kalinga"/>
+        <a:font script="Mlym" typeface="Kartika"/>
+        <a:font script="Laoo" typeface="DokChampa"/>
+        <a:font script="Sinh" typeface="Iskoola Pota"/>
+        <a:font script="Mong" typeface="Mongolian Baiti"/>
+        <a:font script="Viet" typeface="Times New Roman"/>
+        <a:font script="Uigh" typeface="Microsoft Uighur"/>
+        <a:font script="Geor" typeface="Sylfaen"/>
+      </a:majorFont>
+      <a:minorFont>
+        <a:latin typeface="Arial"/>
+        <a:ea typeface=""/>
+        <a:cs typeface=""/>
+        <a:font script="Jpan" typeface="ＭＳ Ｐゴシック"/>
+        <a:font script="Hang" typeface="맑은 고딕"/>
+        <a:font script="Hans" typeface="宋体"/>
+        <a:font script="Hant" typeface="新細明體"/>
+        <a:font script="Arab" typeface="Arial"/>
+        <a:font script="Hebr" typeface="Arial"/>
+        <a:font script="Thai" typeface="Cordia New"/>
+        <a:font script="Ethi" typeface="Nyala"/>
+        <a:font script="Beng" typeface="Vrinda"/>
+        <a:font script="Gujr" typeface="Shruti"/>
+        <a:font script="Khmr" typeface="DaunPenh"/>
+        <a:font script="Knda" typeface="Tunga"/>
+        <a:font script="Guru" typeface="Raavi"/>
+        <a:font script="Cans" typeface="Euphemia"/>
+        <a:font script="Cher" typeface="Plantagenet Cherokee"/>
+        <a:font script="Yiii" typeface="Microsoft Yi Baiti"/>
+        <a:font script="Tibt" typeface="Microsoft Himalaya"/>
+        <a:font script="Thaa" typeface="MV Boli"/>
+        <a:font script="Deva" typeface="Mangal"/>
+        <a:font script="Telu" typeface="Gautami"/>
+        <a:font script="Taml" typeface="Latha"/>
+        <a:font script="Syrc" typeface="Estrangelo Edessa"/>
+        <a:font script="Orya" typeface="Kalinga"/>
+        <a:font script="Mlym" typeface="Kartika"/>
+        <a:font script="Laoo" typeface="DokChampa"/>
+        <a:font script="Sinh" typeface="Iskoola Pota"/>
+        <a:font script="Mong" typeface="Mongolian Baiti"/>
+        <a:font script="Viet" typeface="Arial"/>
+        <a:font script="Uigh" typeface="Microsoft Uighur"/>
+        <a:font script="Geor" typeface="Sylfaen"/>
+      </a:minorFont>
+    </a:fontScheme>
+    <a:fmtScheme name="Office">
+      <a:fillStyleLst>
+        <a:solidFill>
+          <a:schemeClr val="phClr"/>
+        </a:solidFill>
+        <a:gradFill rotWithShape="1">
+          <a:gsLst>
+            <a:gs pos="0">
+              <a:schemeClr val="phClr">
+                <a:tint val="50000"/>
+                <a:satMod val="300000"/>
+              </a:schemeClr>
+            </a:gs>
+            <a:gs pos="35000">
+              <a:schemeClr val="phClr">
+                <a:tint val="37000"/>
+                <a:satMod val="300000"/>
+              </a:schemeClr>
+            </a:gs>
+            <a:gs pos="100000">
+              <a:schemeClr val="phClr">
+                <a:tint val="15000"/>
+                <a:satMod val="350000"/>
+              </a:schemeClr>
+            </a:gs>
+          </a:gsLst>
+          <a:lin ang="16200000" scaled="1"/>
+        </a:gradFill>
+        <a:gradFill rotWithShape="1">
+          <a:gsLst>
+            <a:gs pos="0">
+              <a:schemeClr val="phClr">
+                <a:tint val="100000"/>
+                <a:shade val="100000"/>
+                <a:satMod val="130000"/>
+              </a:schemeClr>
+            </a:gs>
+            <a:gs pos="100000">
+              <a:schemeClr val="phClr">
+                <a:tint val="50000"/>
+                <a:shade val="100000"/>
+                <a:satMod val="350000"/>
+              </a:schemeClr>
+            </a:gs>
+          </a:gsLst>
+          <a:lin ang="16200000" scaled="0"/>
+        </a:gradFill>
+      </a:fillStyleLst>
+      <a:lnStyleLst>
+        <a:ln w="9525" cap="flat" cmpd="sng" algn="ctr">
+          <a:solidFill>
+            <a:schemeClr val="phClr">
+              <a:shade val="95000"/>
+              <a:satMod val="105000"/>
+            </a:schemeClr>
+          </a:solidFill>
+          <a:prstDash val="solid"/>
+        </a:ln>
+        <a:ln w="25400" cap="flat" cmpd="sng" algn="ctr">
+          <a:solidFill>
+            <a:schemeClr val="phClr"/>
+          </a:solidFill>
+          <a:prstDash val="solid"/>
+        </a:ln>
+        <a:ln w="38100" cap="flat" cmpd="sng" algn="ctr">
+          <a:solidFill>
+            <a:schemeClr val="phClr"/>
+          </a:solidFill>
+          <a:prstDash val="solid"/>
+        </a:ln>
+      </a:lnStyleLst>
+      <a:effectStyleLst>
+        <a:effectStyle>
+          <a:effectLst>
+            <a:outerShdw blurRad="40000" dist="20000" dir="5400000" rotWithShape="0">
+              <a:srgbClr val="000000">
+                <a:alpha val="38000"/>
+              </a:srgbClr>
+            </a:outerShdw>
+          </a:effectLst>
+        </a:effectStyle>
+        <a:effectStyle>
+          <a:effectLst>
+            <a:outerShdw blurRad="40000" dist="23000" dir="5400000" rotWithShape="0">
+              <a:srgbClr val="000000">
+                <a:alpha val="35000"/>
+              </a:srgbClr>
+            </a:outerShdw>
+          </a:effectLst>
+        </a:effectStyle>
+        <a:effectStyle>
+          <a:effectLst>
+            <a:outerShdw blurRad="40000" dist="23000" dir="5400000" rotWithShape="0">
+              <a:srgbClr val="000000">
+                <a:alpha val="35000"/>
+              </a:srgbClr>
+            </a:outerShdw>
+          </a:effectLst>
+          <a:scene3d>
+            <a:camera prst="orthographicFront">
+              <a:rot lat="0" lon="0" rev="0"/>
+            </a:camera>
+            <a:lightRig rig="threePt" dir="t">
+              <a:rot lat="0" lon="0" rev="1200000"/>
+            </a:lightRig>
+          </a:scene3d>
+          <a:sp3d>
+            <a:bevelT w="63500" h="25400"/>
+          </a:sp3d>
+        </a:effectStyle>
+      </a:effectStyleLst>
+      <a:bgFillStyleLst>
+        <a:solidFill>
+          <a:schemeClr val="phClr"/>
+        </a:solidFill>
+        <a:gradFill rotWithShape="1">
+          <a:gsLst>
+            <a:gs pos="0">
+              <a:schemeClr val="phClr">
+                <a:tint val="40000"/>
+                <a:satMod val="350000"/>
+              </a:schemeClr>
+            </a:gs>
+            <a:gs pos="40000">
+              <a:schemeClr val="phClr">
+                <a:tint val="45000"/>
+                <a:shade val="99000"/>
+                <a:satMod val="350000"/>
+              </a:schemeClr>
+            </a:gs>
+            <a:gs pos="100000">
+              <a:schemeClr val="phClr">
+                <a:shade val="20000"/>
+                <a:satMod val="255000"/>
+              </a:schemeClr>
+            </a:gs>
+          </a:gsLst>
+          <a:path path="circle">
+            <a:fillToRect l="50000" t="-80000" r="50000" b="180000"/>
+          </a:path>
+        </a:gradFill>
+        <a:gradFill rotWithShape="1">
+          <a:gsLst>
+            <a:gs pos="0">
+              <a:schemeClr val="phClr">
+                <a:tint val="80000"/>
+                <a:satMod val="300000"/>
+              </a:schemeClr>
+            </a:gs>
+            <a:gs pos="100000">
+              <a:schemeClr val="phClr">
+                <a:shade val="30000"/>
+                <a:satMod val="200000"/>
+              </a:schemeClr>
+            </a:gs>
+          </a:gsLst>
+          <a:path path="circle">
+            <a:fillToRect l="50000" t="50000" r="50000" b="50000"/>
+          </a:path>
+        </a:gradFill>
+      </a:bgFillStyleLst>
+    </a:fmtScheme>
+  </a:themeElements>
+</a:theme>
+</file>
+
+<file path=ppt/theme/theme2.xml><?xml version="1.0" encoding="utf-8"?>
 <a:theme xmlns:a="http://schemas.openxmlformats.org/drawingml/2006/main" xmlns:r="http://schemas.openxmlformats.org/officeDocument/2006/relationships" name="Office 테마">
   <a:themeElements>
     <a:clrScheme name="Office">
@@ -13673,283 +14001,4 @@
     </a:fmtScheme>
   </a:themeElements>
 </a:theme>
-</file>
-
-<file path=ppt/theme/theme2.xml><?xml version="1.0" encoding="utf-8"?>
-<a:theme xmlns:a="http://schemas.openxmlformats.org/drawingml/2006/main" xmlns:r="http://schemas.openxmlformats.org/officeDocument/2006/relationships" name="Office Theme">
-  <a:themeElements>
-    <a:clrScheme name="Office">
-      <a:dk1>
-        <a:srgbClr val="000000"/>
-      </a:dk1>
-      <a:lt1>
-        <a:srgbClr val="FFFFFF"/>
-      </a:lt1>
-      <a:dk2>
-        <a:srgbClr val="44546A"/>
-      </a:dk2>
-      <a:lt2>
-        <a:srgbClr val="E7E6E6"/>
-      </a:lt2>
-      <a:accent1>
-        <a:srgbClr val="4472C4"/>
-      </a:accent1>
-      <a:accent2>
-        <a:srgbClr val="ED7D31"/>
-      </a:accent2>
-      <a:accent3>
-        <a:srgbClr val="A5A5A5"/>
-      </a:accent3>
-      <a:accent4>
-        <a:srgbClr val="FFC000"/>
-      </a:accent4>
-      <a:accent5>
-        <a:srgbClr val="5B9BD5"/>
-      </a:accent5>
-      <a:accent6>
-        <a:srgbClr val="70AD47"/>
-      </a:accent6>
-      <a:hlink>
-        <a:srgbClr val="0563C1"/>
-      </a:hlink>
-      <a:folHlink>
-        <a:srgbClr val="954F72"/>
-      </a:folHlink>
-    </a:clrScheme>
-    <a:fontScheme name="Office">
-      <a:majorFont>
-        <a:latin typeface="Arial"/>
-        <a:ea typeface=""/>
-        <a:cs typeface=""/>
-        <a:font script="Jpan" typeface="ＭＳ Ｐゴシック"/>
-        <a:font script="Hang" typeface="맑은 고딕"/>
-        <a:font script="Hans" typeface="宋体"/>
-        <a:font script="Hant" typeface="新細明體"/>
-        <a:font script="Arab" typeface="Times New Roman"/>
-        <a:font script="Hebr" typeface="Times New Roman"/>
-        <a:font script="Thai" typeface="Angsana New"/>
-        <a:font script="Ethi" typeface="Nyala"/>
-        <a:font script="Beng" typeface="Vrinda"/>
-        <a:font script="Gujr" typeface="Shruti"/>
-        <a:font script="Khmr" typeface="MoolBoran"/>
-        <a:font script="Knda" typeface="Tunga"/>
-        <a:font script="Guru" typeface="Raavi"/>
-        <a:font script="Cans" typeface="Euphemia"/>
-        <a:font script="Cher" typeface="Plantagenet Cherokee"/>
-        <a:font script="Yiii" typeface="Microsoft Yi Baiti"/>
-        <a:font script="Tibt" typeface="Microsoft Himalaya"/>
-        <a:font script="Thaa" typeface="MV Boli"/>
-        <a:font script="Deva" typeface="Mangal"/>
-        <a:font script="Telu" typeface="Gautami"/>
-        <a:font script="Taml" typeface="Latha"/>
-        <a:font script="Syrc" typeface="Estrangelo Edessa"/>
-        <a:font script="Orya" typeface="Kalinga"/>
-        <a:font script="Mlym" typeface="Kartika"/>
-        <a:font script="Laoo" typeface="DokChampa"/>
-        <a:font script="Sinh" typeface="Iskoola Pota"/>
-        <a:font script="Mong" typeface="Mongolian Baiti"/>
-        <a:font script="Viet" typeface="Times New Roman"/>
-        <a:font script="Uigh" typeface="Microsoft Uighur"/>
-        <a:font script="Geor" typeface="Sylfaen"/>
-      </a:majorFont>
-      <a:minorFont>
-        <a:latin typeface="Arial"/>
-        <a:ea typeface=""/>
-        <a:cs typeface=""/>
-        <a:font script="Jpan" typeface="ＭＳ Ｐゴシック"/>
-        <a:font script="Hang" typeface="맑은 고딕"/>
-        <a:font script="Hans" typeface="宋体"/>
-        <a:font script="Hant" typeface="新細明體"/>
-        <a:font script="Arab" typeface="Arial"/>
-        <a:font script="Hebr" typeface="Arial"/>
-        <a:font script="Thai" typeface="Cordia New"/>
-        <a:font script="Ethi" typeface="Nyala"/>
-        <a:font script="Beng" typeface="Vrinda"/>
-        <a:font script="Gujr" typeface="Shruti"/>
-        <a:font script="Khmr" typeface="DaunPenh"/>
-        <a:font script="Knda" typeface="Tunga"/>
-        <a:font script="Guru" typeface="Raavi"/>
-        <a:font script="Cans" typeface="Euphemia"/>
-        <a:font script="Cher" typeface="Plantagenet Cherokee"/>
-        <a:font script="Yiii" typeface="Microsoft Yi Baiti"/>
-        <a:font script="Tibt" typeface="Microsoft Himalaya"/>
-        <a:font script="Thaa" typeface="MV Boli"/>
-        <a:font script="Deva" typeface="Mangal"/>
-        <a:font script="Telu" typeface="Gautami"/>
-        <a:font script="Taml" typeface="Latha"/>
-        <a:font script="Syrc" typeface="Estrangelo Edessa"/>
-        <a:font script="Orya" typeface="Kalinga"/>
-        <a:font script="Mlym" typeface="Kartika"/>
-        <a:font script="Laoo" typeface="DokChampa"/>
-        <a:font script="Sinh" typeface="Iskoola Pota"/>
-        <a:font script="Mong" typeface="Mongolian Baiti"/>
-        <a:font script="Viet" typeface="Arial"/>
-        <a:font script="Uigh" typeface="Microsoft Uighur"/>
-        <a:font script="Geor" typeface="Sylfaen"/>
-      </a:minorFont>
-    </a:fontScheme>
-    <a:fmtScheme name="Office">
-      <a:fillStyleLst>
-        <a:solidFill>
-          <a:schemeClr val="phClr"/>
-        </a:solidFill>
-        <a:gradFill rotWithShape="1">
-          <a:gsLst>
-            <a:gs pos="0">
-              <a:schemeClr val="phClr">
-                <a:tint val="50000"/>
-                <a:satMod val="300000"/>
-              </a:schemeClr>
-            </a:gs>
-            <a:gs pos="35000">
-              <a:schemeClr val="phClr">
-                <a:tint val="37000"/>
-                <a:satMod val="300000"/>
-              </a:schemeClr>
-            </a:gs>
-            <a:gs pos="100000">
-              <a:schemeClr val="phClr">
-                <a:tint val="15000"/>
-                <a:satMod val="350000"/>
-              </a:schemeClr>
-            </a:gs>
-          </a:gsLst>
-          <a:lin ang="16200000" scaled="1"/>
-        </a:gradFill>
-        <a:gradFill rotWithShape="1">
-          <a:gsLst>
-            <a:gs pos="0">
-              <a:schemeClr val="phClr">
-                <a:tint val="100000"/>
-                <a:shade val="100000"/>
-                <a:satMod val="130000"/>
-              </a:schemeClr>
-            </a:gs>
-            <a:gs pos="100000">
-              <a:schemeClr val="phClr">
-                <a:tint val="50000"/>
-                <a:shade val="100000"/>
-                <a:satMod val="350000"/>
-              </a:schemeClr>
-            </a:gs>
-          </a:gsLst>
-          <a:lin ang="16200000" scaled="0"/>
-        </a:gradFill>
-      </a:fillStyleLst>
-      <a:lnStyleLst>
-        <a:ln w="9525" cap="flat" cmpd="sng" algn="ctr">
-          <a:solidFill>
-            <a:schemeClr val="phClr">
-              <a:shade val="95000"/>
-              <a:satMod val="105000"/>
-            </a:schemeClr>
-          </a:solidFill>
-          <a:prstDash val="solid"/>
-        </a:ln>
-        <a:ln w="25400" cap="flat" cmpd="sng" algn="ctr">
-          <a:solidFill>
-            <a:schemeClr val="phClr"/>
-          </a:solidFill>
-          <a:prstDash val="solid"/>
-        </a:ln>
-        <a:ln w="38100" cap="flat" cmpd="sng" algn="ctr">
-          <a:solidFill>
-            <a:schemeClr val="phClr"/>
-          </a:solidFill>
-          <a:prstDash val="solid"/>
-        </a:ln>
-      </a:lnStyleLst>
-      <a:effectStyleLst>
-        <a:effectStyle>
-          <a:effectLst>
-            <a:outerShdw blurRad="40000" dist="20000" dir="5400000" rotWithShape="0">
-              <a:srgbClr val="000000">
-                <a:alpha val="38000"/>
-              </a:srgbClr>
-            </a:outerShdw>
-          </a:effectLst>
-        </a:effectStyle>
-        <a:effectStyle>
-          <a:effectLst>
-            <a:outerShdw blurRad="40000" dist="23000" dir="5400000" rotWithShape="0">
-              <a:srgbClr val="000000">
-                <a:alpha val="35000"/>
-              </a:srgbClr>
-            </a:outerShdw>
-          </a:effectLst>
-        </a:effectStyle>
-        <a:effectStyle>
-          <a:effectLst>
-            <a:outerShdw blurRad="40000" dist="23000" dir="5400000" rotWithShape="0">
-              <a:srgbClr val="000000">
-                <a:alpha val="35000"/>
-              </a:srgbClr>
-            </a:outerShdw>
-          </a:effectLst>
-          <a:scene3d>
-            <a:camera prst="orthographicFront">
-              <a:rot lat="0" lon="0" rev="0"/>
-            </a:camera>
-            <a:lightRig rig="threePt" dir="t">
-              <a:rot lat="0" lon="0" rev="1200000"/>
-            </a:lightRig>
-          </a:scene3d>
-          <a:sp3d>
-            <a:bevelT w="63500" h="25400"/>
-          </a:sp3d>
-        </a:effectStyle>
-      </a:effectStyleLst>
-      <a:bgFillStyleLst>
-        <a:solidFill>
-          <a:schemeClr val="phClr"/>
-        </a:solidFill>
-        <a:gradFill rotWithShape="1">
-          <a:gsLst>
-            <a:gs pos="0">
-              <a:schemeClr val="phClr">
-                <a:tint val="40000"/>
-                <a:satMod val="350000"/>
-              </a:schemeClr>
-            </a:gs>
-            <a:gs pos="40000">
-              <a:schemeClr val="phClr">
-                <a:tint val="45000"/>
-                <a:shade val="99000"/>
-                <a:satMod val="350000"/>
-              </a:schemeClr>
-            </a:gs>
-            <a:gs pos="100000">
-              <a:schemeClr val="phClr">
-                <a:shade val="20000"/>
-                <a:satMod val="255000"/>
-              </a:schemeClr>
-            </a:gs>
-          </a:gsLst>
-          <a:path path="circle">
-            <a:fillToRect l="50000" t="-80000" r="50000" b="180000"/>
-          </a:path>
-        </a:gradFill>
-        <a:gradFill rotWithShape="1">
-          <a:gsLst>
-            <a:gs pos="0">
-              <a:schemeClr val="phClr">
-                <a:tint val="80000"/>
-                <a:satMod val="300000"/>
-              </a:schemeClr>
-            </a:gs>
-            <a:gs pos="100000">
-              <a:schemeClr val="phClr">
-                <a:shade val="30000"/>
-                <a:satMod val="200000"/>
-              </a:schemeClr>
-            </a:gs>
-          </a:gsLst>
-          <a:path path="circle">
-            <a:fillToRect l="50000" t="50000" r="50000" b="50000"/>
-          </a:path>
-        </a:gradFill>
-      </a:bgFillStyleLst>
-    </a:fmtScheme>
-  </a:themeElements>
-</a:theme>
 </file>
</xml_diff>

<commit_message>
docs: 업데이트된 ReSet_Presentation.pptx 파일 추가
</commit_message>
<xml_diff>
--- a/docs/ReSet_Presentation.pptx
+++ b/docs/ReSet_Presentation.pptx
@@ -9345,7 +9345,7 @@
                 <a:cs typeface="Calibri"/>
                 <a:sym typeface="Calibri"/>
               </a:rPr>
-              <a:t>이종 Critic 에이전트의 4대 기준 평가 피드백 획득</a:t>
+              <a:t>이종 Critic 에이전트의 5대 기준 평가 피드백 획득</a:t>
             </a:r>
             <a:endParaRPr sz="1050">
               <a:solidFill>
@@ -11763,7 +11763,7 @@
                 <a:cs typeface="Calibri"/>
                 <a:sym typeface="Calibri"/>
               </a:rPr>
-              <a:t>C# 리플렉션 로드 후 DB 트랜잭션 Rollback 강제 적용 또는 Java 외부 프로세스 타임아웃 구동 결과 JSON 수집</a:t>
+              <a:t>동적 라이브러리 로딩 및 트랜잭션 강제 롤백을 통한 데이터베이스 격리, 또는 독립 프로세스 기동 및 타임아웃 제어를 통한 런타임 격리를 적용하여 대상 로직의 수행 결과를 JSON 포맷의 스트림으로 수집</a:t>
             </a:r>
             <a:endParaRPr sz="1050">
               <a:solidFill>
@@ -13275,7 +13275,7 @@
                 <a:cs typeface="Calibri"/>
                 <a:sym typeface="Calibri"/>
               </a:rPr>
-              <a:t>YAML TargetCode 기반 경로 매핑</a:t>
+              <a:t>Sandbox 결과 1:1 비교</a:t>
             </a:r>
             <a:endParaRPr sz="1050">
               <a:solidFill>
@@ -13312,7 +13312,7 @@
                 <a:cs typeface="Calibri"/>
                 <a:sym typeface="Calibri"/>
               </a:rPr>
-              <a:t>Sandbox 결과 1:1 비교</a:t>
+              <a:t>관계형 모의 데이터 적재/소거</a:t>
             </a:r>
             <a:endParaRPr sz="1050">
               <a:solidFill>
@@ -13349,7 +13349,7 @@
                 <a:cs typeface="Calibri"/>
                 <a:sym typeface="Calibri"/>
               </a:rPr>
-              <a:t>관계형 모의 데이터 적재/소거</a:t>
+              <a:t>양방향 실행 덤프 값 정밀 대조</a:t>
             </a:r>
             <a:endParaRPr sz="1050">
               <a:solidFill>
@@ -13386,7 +13386,7 @@
                 <a:cs typeface="Calibri"/>
                 <a:sym typeface="Calibri"/>
               </a:rPr>
-              <a:t>양방향 실행 덤프 값 정밀 대조</a:t>
+              <a:t>정합성 결함 시 3단계 복구 루프</a:t>
             </a:r>
             <a:endParaRPr sz="1050">
               <a:solidFill>
@@ -13399,7 +13399,7 @@
             </a:endParaRPr>
           </a:p>
           <a:p>
-            <a:pPr indent="-182563" lvl="0" marL="182563" marR="0" rtl="0" algn="l">
+            <a:pPr indent="-160338" lvl="0" marL="342900" rtl="0" algn="l">
               <a:spcBef>
                 <a:spcPts val="500"/>
               </a:spcBef>
@@ -13410,8 +13410,8 @@
                 <a:srgbClr val="1E293B"/>
               </a:buClr>
               <a:buSzPts val="1050"/>
-              <a:buFont typeface="Noto Sans Symbols"/>
-              <a:buChar char="✔"/>
+              <a:buFont typeface="Calibri"/>
+              <a:buChar char="•"/>
             </a:pPr>
             <a:r>
               <a:rPr lang="en-US" sz="1050">
@@ -13423,11 +13423,85 @@
                 <a:cs typeface="Calibri"/>
                 <a:sym typeface="Calibri"/>
               </a:rPr>
-              <a:t>정합성 결함 시 3단계 복구 루프</a:t>
+              <a:t>설계 재수립</a:t>
             </a:r>
             <a:endParaRPr sz="1050">
               <a:solidFill>
-                <a:schemeClr val="dk1"/>
+                <a:srgbClr val="1E293B"/>
+              </a:solidFill>
+              <a:latin typeface="Calibri"/>
+              <a:ea typeface="Calibri"/>
+              <a:cs typeface="Calibri"/>
+              <a:sym typeface="Calibri"/>
+            </a:endParaRPr>
+          </a:p>
+          <a:p>
+            <a:pPr indent="-160338" lvl="0" marL="342900" rtl="0" algn="l">
+              <a:spcBef>
+                <a:spcPts val="500"/>
+              </a:spcBef>
+              <a:spcAft>
+                <a:spcPts val="0"/>
+              </a:spcAft>
+              <a:buClr>
+                <a:srgbClr val="1E293B"/>
+              </a:buClr>
+              <a:buSzPts val="1050"/>
+              <a:buFont typeface="Calibri"/>
+              <a:buChar char="•"/>
+            </a:pPr>
+            <a:r>
+              <a:rPr lang="en-US" sz="1050">
+                <a:solidFill>
+                  <a:srgbClr val="1E293B"/>
+                </a:solidFill>
+                <a:latin typeface="Calibri"/>
+                <a:ea typeface="Calibri"/>
+                <a:cs typeface="Calibri"/>
+                <a:sym typeface="Calibri"/>
+              </a:rPr>
+              <a:t>소스코드 보완</a:t>
+            </a:r>
+            <a:endParaRPr sz="1050">
+              <a:solidFill>
+                <a:srgbClr val="1E293B"/>
+              </a:solidFill>
+              <a:latin typeface="Calibri"/>
+              <a:ea typeface="Calibri"/>
+              <a:cs typeface="Calibri"/>
+              <a:sym typeface="Calibri"/>
+            </a:endParaRPr>
+          </a:p>
+          <a:p>
+            <a:pPr indent="-160338" lvl="0" marL="342900" rtl="0" algn="l">
+              <a:spcBef>
+                <a:spcPts val="500"/>
+              </a:spcBef>
+              <a:spcAft>
+                <a:spcPts val="0"/>
+              </a:spcAft>
+              <a:buClr>
+                <a:srgbClr val="1E293B"/>
+              </a:buClr>
+              <a:buSzPts val="1050"/>
+              <a:buFont typeface="Calibri"/>
+              <a:buChar char="•"/>
+            </a:pPr>
+            <a:r>
+              <a:rPr lang="en-US" sz="1050">
+                <a:solidFill>
+                  <a:srgbClr val="1E293B"/>
+                </a:solidFill>
+                <a:latin typeface="Calibri"/>
+                <a:ea typeface="Calibri"/>
+                <a:cs typeface="Calibri"/>
+                <a:sym typeface="Calibri"/>
+              </a:rPr>
+              <a:t>테스트 튜닝</a:t>
+            </a:r>
+            <a:endParaRPr sz="1050">
+              <a:solidFill>
+                <a:srgbClr val="1E293B"/>
               </a:solidFill>
               <a:latin typeface="Calibri"/>
               <a:ea typeface="Calibri"/>

</xml_diff>

<commit_message>
docs: update presentation with TDD & self-correction features
</commit_message>
<xml_diff>
--- a/docs/ReSet_Presentation.pptx
+++ b/docs/ReSet_Presentation.pptx
@@ -3840,7 +3840,7 @@
                 <a:cs typeface="Trebuchet MS"/>
                 <a:sym typeface="Trebuchet MS"/>
               </a:rPr>
-              <a:t>분석 및 </a:t>
+              <a:t xml:space="preserve">분석 및 </a:t>
             </a:r>
             <a:r>
               <a:rPr b="1" lang="en-US" sz="1300">
@@ -4123,7 +4123,7 @@
                 <a:cs typeface="Trebuchet MS"/>
                 <a:sym typeface="Trebuchet MS"/>
               </a:rPr>
-              <a:t>설계 산출물 결함률 </a:t>
+              <a:t xml:space="preserve">설계 산출물 결함률 </a:t>
             </a:r>
             <a:r>
               <a:rPr b="1" lang="en-US" sz="1300">
@@ -4665,7 +4665,7 @@
                 <a:cs typeface="Calibri"/>
                 <a:sym typeface="Calibri"/>
               </a:rPr>
-              <a:t>레거시 DB의 내부 로직(SP) 현대화는 </a:t>
+              <a:t xml:space="preserve">레거시 DB의 내부 로직(SP) 현대화는 </a:t>
             </a:r>
             <a:r>
               <a:rPr lang="en-US" sz="1500">
@@ -6114,7 +6114,7 @@
                 <a:cs typeface="Calibri"/>
                 <a:sym typeface="Calibri"/>
               </a:rPr>
-              <a:t>T-SQL AST </a:t>
+              <a:t xml:space="preserve">T-SQL AST </a:t>
             </a:r>
             <a:r>
               <a:rPr lang="en-US" sz="1150">
@@ -6553,6 +6553,43 @@
                 <a:sym typeface="Calibri"/>
               </a:rPr>
               <a:t>양방향 런타임 결과 수집 및 1:1 값 정밀 대조</a:t>
+            </a:r>
+            <a:endParaRPr sz="1150">
+              <a:solidFill>
+                <a:schemeClr val="dk1"/>
+              </a:solidFill>
+              <a:latin typeface="Calibri"/>
+              <a:ea typeface="Calibri"/>
+              <a:cs typeface="Calibri"/>
+              <a:sym typeface="Calibri"/>
+            </a:endParaRPr>
+          </a:p>
+          <a:p>
+            <a:pPr indent="-182563" lvl="0" marL="182563" marR="0" rtl="0" algn="l">
+              <a:spcBef>
+                <a:spcPts val="1200"/>
+              </a:spcBef>
+              <a:spcAft>
+                <a:spcPts val="0"/>
+              </a:spcAft>
+              <a:buClr>
+                <a:srgbClr val="1E293B"/>
+              </a:buClr>
+              <a:buSzPts val="1150"/>
+              <a:buFont typeface="Noto Sans Symbols"/>
+              <a:buChar char="✔"/>
+            </a:pPr>
+            <a:r>
+              <a:rPr lang="en-US" sz="1150">
+                <a:solidFill>
+                  <a:srgbClr val="1E293B"/>
+                </a:solidFill>
+                <a:latin typeface="Calibri"/>
+                <a:ea typeface="Calibri"/>
+                <a:cs typeface="Calibri"/>
+                <a:sym typeface="Calibri"/>
+              </a:rPr>
+              <a:t>TDD용 단위 테스트 및 ArchUnit 아키텍처 규칙 검증 코드 자동 설계</a:t>
             </a:r>
             <a:endParaRPr sz="1150">
               <a:solidFill>
@@ -12972,6 +13009,43 @@
                 <a:sym typeface="Calibri"/>
               </a:rPr>
               <a:t>취소 시 좀비 방지 트리 강제 정리</a:t>
+            </a:r>
+            <a:endParaRPr sz="1050">
+              <a:solidFill>
+                <a:schemeClr val="dk1"/>
+              </a:solidFill>
+              <a:latin typeface="Calibri"/>
+              <a:ea typeface="Calibri"/>
+              <a:cs typeface="Calibri"/>
+              <a:sym typeface="Calibri"/>
+            </a:endParaRPr>
+          </a:p>
+          <a:p>
+            <a:pPr indent="-182563" lvl="0" marL="182563" marR="0" rtl="0" algn="l">
+              <a:spcBef>
+                <a:spcPts val="500"/>
+              </a:spcBef>
+              <a:spcAft>
+                <a:spcPts val="0"/>
+              </a:spcAft>
+              <a:buClr>
+                <a:srgbClr val="1E293B"/>
+              </a:buClr>
+              <a:buSzPts val="1050"/>
+              <a:buFont typeface="Noto Sans Symbols"/>
+              <a:buChar char="✔"/>
+            </a:pPr>
+            <a:r>
+              <a:rPr lang="en-US" sz="1050">
+                <a:solidFill>
+                  <a:srgbClr val="1E293B"/>
+                </a:solidFill>
+                <a:latin typeface="Calibri"/>
+                <a:ea typeface="Calibri"/>
+                <a:cs typeface="Calibri"/>
+                <a:sym typeface="Calibri"/>
+              </a:rPr>
+              <a:t>TDD 테스트 사전 공급 &amp; 자가 수정 피드백 루프</a:t>
             </a:r>
             <a:endParaRPr sz="1050">
               <a:solidFill>

</xml_diff>

<commit_message>
docs: refine Slide 3 architecture and order in ReSet_Presentation.pptx
</commit_message>
<xml_diff>
--- a/docs/ReSet_Presentation.pptx
+++ b/docs/ReSet_Presentation.pptx
@@ -6077,31 +6077,31 @@
                 <a:cs typeface="Calibri"/>
                 <a:sym typeface="Calibri"/>
               </a:rPr>
-              <a:t>확장 속성(Description) 수집 및 설명 누락 AI 보완</a:t>
+              <a:t>T-SQL AST 기반 정적 분석 및 CRUD 테이블 기계적 분류 (ScriptDom)</a:t>
             </a:r>
             <a:endParaRPr sz="1150">
               <a:solidFill>
+                <a:schemeClr val="dk1"/>
+              </a:solidFill>
+              <a:latin typeface="Calibri"/>
+              <a:ea typeface="Calibri"/>
+              <a:cs typeface="Calibri"/>
+              <a:sym typeface="Calibri"/>
+            </a:endParaRPr>
+          </a:p>
+          <a:p>
+            <a:pPr indent="-182563" lvl="0" marL="182563" marR="0" rtl="0" algn="l">
+              <a:spcBef>
+                <a:spcPts val="1200"/>
+              </a:spcBef>
+              <a:spcAft>
+                <a:spcPts val="0"/>
+              </a:spcAft>
+              <a:buClr>
                 <a:srgbClr val="1E293B"/>
-              </a:solidFill>
-              <a:latin typeface="Calibri"/>
-              <a:ea typeface="Calibri"/>
-              <a:cs typeface="Calibri"/>
-              <a:sym typeface="Calibri"/>
-            </a:endParaRPr>
-          </a:p>
-          <a:p>
-            <a:pPr indent="-182563" lvl="0" marL="182563" marR="0" rtl="0" algn="l">
-              <a:spcBef>
-                <a:spcPts val="1200"/>
-              </a:spcBef>
-              <a:spcAft>
-                <a:spcPts val="0"/>
-              </a:spcAft>
-              <a:buClr>
-                <a:srgbClr val="1E293B"/>
               </a:buClr>
               <a:buSzPts val="1150"/>
-              <a:buFont typeface="Calibri"/>
+              <a:buFont typeface="Noto Sans Symbols"/>
               <a:buChar char="✔"/>
             </a:pPr>
             <a:r>
@@ -6114,8 +6114,33 @@
                 <a:cs typeface="Calibri"/>
                 <a:sym typeface="Calibri"/>
               </a:rPr>
-              <a:t xml:space="preserve">T-SQL AST </a:t>
-            </a:r>
+              <a:t>하이브리드 동적 SQL 및 Linked Server 원격 참조 정밀 탐지</a:t>
+            </a:r>
+            <a:endParaRPr sz="1150">
+              <a:solidFill>
+                <a:schemeClr val="dk1"/>
+              </a:solidFill>
+              <a:latin typeface="Calibri"/>
+              <a:ea typeface="Calibri"/>
+              <a:cs typeface="Calibri"/>
+              <a:sym typeface="Calibri"/>
+            </a:endParaRPr>
+          </a:p>
+          <a:p>
+            <a:pPr indent="-182563" lvl="0" marL="182563" marR="0" rtl="0" algn="l">
+              <a:spcBef>
+                <a:spcPts val="1200"/>
+              </a:spcBef>
+              <a:spcAft>
+                <a:spcPts val="0"/>
+              </a:spcAft>
+              <a:buClr>
+                <a:srgbClr val="1E293B"/>
+              </a:buClr>
+              <a:buSzPts val="1150"/>
+              <a:buFont typeface="Noto Sans Symbols"/>
+              <a:buChar char="✔"/>
+            </a:pPr>
             <a:r>
               <a:rPr lang="en-US" sz="1150">
                 <a:solidFill>
@@ -6126,11 +6151,11 @@
                 <a:cs typeface="Calibri"/>
                 <a:sym typeface="Calibri"/>
               </a:rPr>
-              <a:t>기반 정적 분석 (ScriptDom)</a:t>
+              <a:t>확장 속성(Description) 수집 및 설명 누락 AI 문맥 보완</a:t>
             </a:r>
             <a:endParaRPr sz="1150">
               <a:solidFill>
-                <a:srgbClr val="1E293B"/>
+                <a:schemeClr val="dk1"/>
               </a:solidFill>
               <a:latin typeface="Calibri"/>
               <a:ea typeface="Calibri"/>
@@ -6163,7 +6188,7 @@
                 <a:cs typeface="Calibri"/>
                 <a:sym typeface="Calibri"/>
               </a:rPr>
-              <a:t>코드-주석 불일치 감지 및 클렌징 SQL 스크립트 덤프</a:t>
+              <a:t>코드-주석 불일치 모순 감지 및 클렌징 SQL 스크립트 자동 덤프</a:t>
             </a:r>
             <a:endParaRPr sz="1150">
               <a:solidFill>
@@ -6200,7 +6225,7 @@
                 <a:cs typeface="Calibri"/>
                 <a:sym typeface="Calibri"/>
               </a:rPr>
-              <a:t>3단계 신뢰성 검증 파이프라인</a:t>
+              <a:t>3단계 신뢰성 검증 파이프라인 (L1 린터 ➔ L2 AI리뷰 ➔ L3 인간 승인)</a:t>
             </a:r>
             <a:endParaRPr sz="1150">
               <a:solidFill>
@@ -6441,7 +6466,7 @@
                 <a:cs typeface="Calibri"/>
                 <a:sym typeface="Calibri"/>
               </a:rPr>
-              <a:t>설계서 vs 신규 구현 소스코드 논리 Gap 분석</a:t>
+              <a:t>TDD용 단위 테스트 및 ArchUnit 아키텍처 제약 규칙 자동 설계 (선제 공급)</a:t>
             </a:r>
             <a:endParaRPr sz="1150">
               <a:solidFill>
@@ -6478,7 +6503,7 @@
                 <a:cs typeface="Calibri"/>
                 <a:sym typeface="Calibri"/>
               </a:rPr>
-              <a:t>테스트 케이스 및 참조 무결성 기반 모의 데이터 자동 설계</a:t>
+              <a:t>설계서 vs 신규 구현 소스코드 논리 Gap 분석 (L1/L2 구조 검증)</a:t>
             </a:r>
             <a:endParaRPr sz="1150">
               <a:solidFill>
@@ -6515,7 +6540,7 @@
                 <a:cs typeface="Calibri"/>
                 <a:sym typeface="Calibri"/>
               </a:rPr>
-              <a:t>샌드박스 DB Seeding 라이프사이클 격리 및 관리</a:t>
+              <a:t>테스트 케이스 및 참조 무결성 기반 모의 데이터 자동 설계</a:t>
             </a:r>
             <a:endParaRPr sz="1150">
               <a:solidFill>
@@ -6552,7 +6577,7 @@
                 <a:cs typeface="Calibri"/>
                 <a:sym typeface="Calibri"/>
               </a:rPr>
-              <a:t>양방향 런타임 결과 수집 및 1:1 값 정밀 대조</a:t>
+              <a:t>샌드박스 DB Seeding 및 Cleanup 라이프사이클 격리 관리</a:t>
             </a:r>
             <a:endParaRPr sz="1150">
               <a:solidFill>
@@ -6589,7 +6614,44 @@
                 <a:cs typeface="Calibri"/>
                 <a:sym typeface="Calibri"/>
               </a:rPr>
-              <a:t>TDD용 단위 테스트 및 ArchUnit 아키텍처 규칙 검증 코드 자동 설계</a:t>
+              <a:t>다형성 런타임 격리 실행 (C# 트랜잭션 롤백 및 Java IPC 통신)</a:t>
+            </a:r>
+            <a:endParaRPr sz="1150">
+              <a:solidFill>
+                <a:schemeClr val="dk1"/>
+              </a:solidFill>
+              <a:latin typeface="Calibri"/>
+              <a:ea typeface="Calibri"/>
+              <a:cs typeface="Calibri"/>
+              <a:sym typeface="Calibri"/>
+            </a:endParaRPr>
+          </a:p>
+          <a:p>
+            <a:pPr indent="-182563" lvl="0" marL="182563" marR="0" rtl="0" algn="l">
+              <a:spcBef>
+                <a:spcPts val="1200"/>
+              </a:spcBef>
+              <a:spcAft>
+                <a:spcPts val="0"/>
+              </a:spcAft>
+              <a:buClr>
+                <a:srgbClr val="1E293B"/>
+              </a:buClr>
+              <a:buSzPts val="1150"/>
+              <a:buFont typeface="Noto Sans Symbols"/>
+              <a:buChar char="✔"/>
+            </a:pPr>
+            <a:r>
+              <a:rPr lang="en-US" sz="1150">
+                <a:solidFill>
+                  <a:srgbClr val="1E293B"/>
+                </a:solidFill>
+                <a:latin typeface="Calibri"/>
+                <a:ea typeface="Calibri"/>
+                <a:cs typeface="Calibri"/>
+                <a:sym typeface="Calibri"/>
+              </a:rPr>
+              <a:t>양방향 런타임 결과 수집 및 1:1 값 정밀 대조 (DataComparison)</a:t>
             </a:r>
             <a:endParaRPr sz="1150">
               <a:solidFill>

</xml_diff>

<commit_message>
docs: update Slide 9 roadmap flows in ReSet_Presentation.pptx
</commit_message>
<xml_diff>
--- a/docs/ReSet_Presentation.pptx
+++ b/docs/ReSet_Presentation.pptx
@@ -12433,7 +12433,7 @@
                 <a:cs typeface="Calibri"/>
                 <a:sym typeface="Calibri"/>
               </a:rPr>
-              <a:t>SP DDL &amp; 스키마 수집</a:t>
+              <a:t>SP DDL 및 스키마 정보 재귀 수집</a:t>
             </a:r>
             <a:endParaRPr sz="1050">
               <a:solidFill>
@@ -12470,7 +12470,7 @@
                 <a:cs typeface="Calibri"/>
                 <a:sym typeface="Calibri"/>
               </a:rPr>
-              <a:t>의존성 추적</a:t>
+              <a:t>DDL 해시 시그니처 기반 로컬 증분 분석 캐싱</a:t>
             </a:r>
             <a:endParaRPr sz="1050">
               <a:solidFill>
@@ -12483,33 +12483,28 @@
             </a:endParaRPr>
           </a:p>
           <a:p>
-            <a:pPr indent="-182563" lvl="0" marL="182563" marR="0" rtl="0" algn="l">
-              <a:spcBef>
-                <a:spcPts val="500"/>
-              </a:spcBef>
-              <a:spcAft>
-                <a:spcPts val="0"/>
-              </a:spcAft>
-              <a:buClr>
-                <a:srgbClr val="1E293B"/>
-              </a:buClr>
-              <a:buSzPts val="1050"/>
-              <a:buFont typeface="Noto Sans Symbols"/>
-              <a:buChar char="✔"/>
-            </a:pPr>
-            <a:r>
-              <a:rPr lang="en-US" sz="1050">
-                <a:solidFill>
-                  <a:srgbClr val="1E293B"/>
+            <a:pPr indent="-142875" lvl="1" marL="325438" marR="0" rtl="0" algn="l">
+              <a:spcBef>
+                <a:spcPts val="200"/>
+              </a:spcBef>
+              <a:spcAft>
+                <a:spcPts val="0"/>
+              </a:spcAft>
+              <a:buNone/>
+            </a:pPr>
+            <a:r>
+              <a:rPr lang="en-US" sz="950">
+                <a:solidFill>
+                  <a:srgbClr val="475569"/>
                 </a:solidFill>
                 <a:latin typeface="Calibri"/>
                 <a:ea typeface="Calibri"/>
                 <a:cs typeface="Calibri"/>
                 <a:sym typeface="Calibri"/>
               </a:rPr>
-              <a:t>3단계 신뢰성 검증 파이프라인</a:t>
-            </a:r>
-            <a:endParaRPr sz="1050">
+              <a:t>- API 토큰 비용 및 대기 시간 최소화</a:t>
+            </a:r>
+            <a:endParaRPr sz="950">
               <a:solidFill>
                 <a:schemeClr val="dk1"/>
               </a:solidFill>
@@ -12544,7 +12539,7 @@
                 <a:cs typeface="Calibri"/>
                 <a:sym typeface="Calibri"/>
               </a:rPr>
-              <a:t>L1/L2 자가보완 및 TUI 미리보기</a:t>
+              <a:t>3단계 신뢰성 검증 파이프라인 (L1~L3) 명세서 확정</a:t>
             </a:r>
             <a:endParaRPr sz="1050">
               <a:solidFill>
@@ -12581,44 +12576,7 @@
                 <a:cs typeface="Calibri"/>
                 <a:sym typeface="Calibri"/>
               </a:rPr>
-              <a:t>DDL 해시 증분 분석 캐싱</a:t>
-            </a:r>
-            <a:endParaRPr sz="1050">
-              <a:solidFill>
-                <a:schemeClr val="dk1"/>
-              </a:solidFill>
-              <a:latin typeface="Calibri"/>
-              <a:ea typeface="Calibri"/>
-              <a:cs typeface="Calibri"/>
-              <a:sym typeface="Calibri"/>
-            </a:endParaRPr>
-          </a:p>
-          <a:p>
-            <a:pPr indent="-182563" lvl="0" marL="182563" marR="0" rtl="0" algn="l">
-              <a:spcBef>
-                <a:spcPts val="500"/>
-              </a:spcBef>
-              <a:spcAft>
-                <a:spcPts val="0"/>
-              </a:spcAft>
-              <a:buClr>
-                <a:srgbClr val="1E293B"/>
-              </a:buClr>
-              <a:buSzPts val="1050"/>
-              <a:buFont typeface="Noto Sans Symbols"/>
-              <a:buChar char="✔"/>
-            </a:pPr>
-            <a:r>
-              <a:rPr lang="en-US" sz="1050">
-                <a:solidFill>
-                  <a:srgbClr val="1E293B"/>
-                </a:solidFill>
-                <a:latin typeface="Calibri"/>
-                <a:ea typeface="Calibri"/>
-                <a:cs typeface="Calibri"/>
-                <a:sym typeface="Calibri"/>
-              </a:rPr>
-              <a:t>API 토큰 비용 및 대기시간 최소화</a:t>
+              <a:t>상수 분기 및 데이터 프로파일링 기반 통합 정산 정책서 도출</a:t>
             </a:r>
             <a:endParaRPr sz="1050">
               <a:solidFill>
@@ -12885,7 +12843,7 @@
                 <a:cs typeface="Calibri"/>
                 <a:sym typeface="Calibri"/>
               </a:rPr>
-              <a:t>TUI 순차 선택 기반 배치 순서 확보</a:t>
+              <a:t>TUI 순차 선택 기반 배치 실행 단계 순서 확보</a:t>
             </a:r>
             <a:endParaRPr sz="1050">
               <a:solidFill>
@@ -12922,7 +12880,7 @@
                 <a:cs typeface="Calibri"/>
                 <a:sym typeface="Calibri"/>
               </a:rPr>
-              <a:t>작업 지시서 번들 패키징</a:t>
+              <a:t>마이그레이션 지시서 번들 패키징 (설계서, DDL, 스키마 통합)</a:t>
             </a:r>
             <a:endParaRPr sz="1050">
               <a:solidFill>
@@ -12959,7 +12917,7 @@
                 <a:cs typeface="Calibri"/>
                 <a:sym typeface="Calibri"/>
               </a:rPr>
-              <a:t>설계서 및 DB 메타데이터 번들화</a:t>
+              <a:t>TDD용 단위 테스트 및 ArchUnit 아키텍처 규칙 코드 선제 공급</a:t>
             </a:r>
             <a:endParaRPr sz="1050">
               <a:solidFill>
@@ -12996,7 +12954,7 @@
                 <a:cs typeface="Calibri"/>
                 <a:sym typeface="Calibri"/>
               </a:rPr>
-              <a:t>외부 코딩 에이전트 자동 기동</a:t>
+              <a:t>외부 코딩 에이전트 자동 기동 및 자가 수정 피드백 루프 가동</a:t>
             </a:r>
             <a:endParaRPr sz="1050">
               <a:solidFill>
@@ -13033,81 +12991,7 @@
                 <a:cs typeface="Calibri"/>
                 <a:sym typeface="Calibri"/>
               </a:rPr>
-              <a:t>부모 콘솔 상속 연동 및 양방향 제어</a:t>
-            </a:r>
-            <a:endParaRPr sz="1050">
-              <a:solidFill>
-                <a:schemeClr val="dk1"/>
-              </a:solidFill>
-              <a:latin typeface="Calibri"/>
-              <a:ea typeface="Calibri"/>
-              <a:cs typeface="Calibri"/>
-              <a:sym typeface="Calibri"/>
-            </a:endParaRPr>
-          </a:p>
-          <a:p>
-            <a:pPr indent="-182563" lvl="0" marL="182563" marR="0" rtl="0" algn="l">
-              <a:spcBef>
-                <a:spcPts val="500"/>
-              </a:spcBef>
-              <a:spcAft>
-                <a:spcPts val="0"/>
-              </a:spcAft>
-              <a:buClr>
-                <a:srgbClr val="1E293B"/>
-              </a:buClr>
-              <a:buSzPts val="1050"/>
-              <a:buFont typeface="Noto Sans Symbols"/>
-              <a:buChar char="✔"/>
-            </a:pPr>
-            <a:r>
-              <a:rPr lang="en-US" sz="1050">
-                <a:solidFill>
-                  <a:srgbClr val="1E293B"/>
-                </a:solidFill>
-                <a:latin typeface="Calibri"/>
-                <a:ea typeface="Calibri"/>
-                <a:cs typeface="Calibri"/>
-                <a:sym typeface="Calibri"/>
-              </a:rPr>
-              <a:t>취소 시 좀비 방지 트리 강제 정리</a:t>
-            </a:r>
-            <a:endParaRPr sz="1050">
-              <a:solidFill>
-                <a:schemeClr val="dk1"/>
-              </a:solidFill>
-              <a:latin typeface="Calibri"/>
-              <a:ea typeface="Calibri"/>
-              <a:cs typeface="Calibri"/>
-              <a:sym typeface="Calibri"/>
-            </a:endParaRPr>
-          </a:p>
-          <a:p>
-            <a:pPr indent="-182563" lvl="0" marL="182563" marR="0" rtl="0" algn="l">
-              <a:spcBef>
-                <a:spcPts val="500"/>
-              </a:spcBef>
-              <a:spcAft>
-                <a:spcPts val="0"/>
-              </a:spcAft>
-              <a:buClr>
-                <a:srgbClr val="1E293B"/>
-              </a:buClr>
-              <a:buSzPts val="1050"/>
-              <a:buFont typeface="Noto Sans Symbols"/>
-              <a:buChar char="✔"/>
-            </a:pPr>
-            <a:r>
-              <a:rPr lang="en-US" sz="1050">
-                <a:solidFill>
-                  <a:srgbClr val="1E293B"/>
-                </a:solidFill>
-                <a:latin typeface="Calibri"/>
-                <a:ea typeface="Calibri"/>
-                <a:cs typeface="Calibri"/>
-                <a:sym typeface="Calibri"/>
-              </a:rPr>
-              <a:t>TDD 테스트 사전 공급 &amp; 자가 수정 피드백 루프</a:t>
+              <a:t>부모 콘솔 상속 연동 및 좀비 프로세스 방지 트리 강제 정리</a:t>
             </a:r>
             <a:endParaRPr sz="1050">
               <a:solidFill>
@@ -13374,7 +13258,7 @@
                 <a:cs typeface="Calibri"/>
                 <a:sym typeface="Calibri"/>
               </a:rPr>
-              <a:t>소스코드-설계서 Gap 분석</a:t>
+              <a:t>소스코드 vs 설계서 구조 및 논리 일치성 Gap 분석</a:t>
             </a:r>
             <a:endParaRPr sz="1050">
               <a:solidFill>
@@ -13411,7 +13295,7 @@
                 <a:cs typeface="Calibri"/>
                 <a:sym typeface="Calibri"/>
               </a:rPr>
-              <a:t>Sandbox 결과 1:1 비교</a:t>
+              <a:t>관계지향 모의 데이터(Mock Data) 자동 설계 및 Sandbox DB 적재</a:t>
             </a:r>
             <a:endParaRPr sz="1050">
               <a:solidFill>
@@ -13448,7 +13332,7 @@
                 <a:cs typeface="Calibri"/>
                 <a:sym typeface="Calibri"/>
               </a:rPr>
-              <a:t>관계형 모의 데이터 적재/소거</a:t>
+              <a:t>양방향(Legacy vs Target) 실행 결과 데이터 수집 및 Sandbox Cleanup</a:t>
             </a:r>
             <a:endParaRPr sz="1050">
               <a:solidFill>
@@ -13485,7 +13369,7 @@
                 <a:cs typeface="Calibri"/>
                 <a:sym typeface="Calibri"/>
               </a:rPr>
-              <a:t>양방향 실행 덤프 값 정밀 대조</a:t>
+              <a:t>결과셋 데이터 1:1 정밀 대조 및 데이터 정합성 비교 보고서 발행</a:t>
             </a:r>
             <a:endParaRPr sz="1050">
               <a:solidFill>
@@ -13522,7 +13406,7 @@
                 <a:cs typeface="Calibri"/>
                 <a:sym typeface="Calibri"/>
               </a:rPr>
-              <a:t>정합성 결함 시 3단계 복구 루프</a:t>
+              <a:t>정합성 결함 발생 시 3단계 복구 피드백 루프 작동</a:t>
             </a:r>
             <a:endParaRPr sz="1050">
               <a:solidFill>
@@ -13559,7 +13443,7 @@
                 <a:cs typeface="Calibri"/>
                 <a:sym typeface="Calibri"/>
               </a:rPr>
-              <a:t>설계 재수립</a:t>
+              <a:t>루프 A (설계서 재수립)</a:t>
             </a:r>
             <a:endParaRPr sz="1050">
               <a:solidFill>
@@ -13596,7 +13480,7 @@
                 <a:cs typeface="Calibri"/>
                 <a:sym typeface="Calibri"/>
               </a:rPr>
-              <a:t>소스코드 보완</a:t>
+              <a:t>루프 B (소스코드 보완)</a:t>
             </a:r>
             <a:endParaRPr sz="1050">
               <a:solidFill>
@@ -13633,7 +13517,7 @@
                 <a:cs typeface="Calibri"/>
                 <a:sym typeface="Calibri"/>
               </a:rPr>
-              <a:t>테스트 튜닝</a:t>
+              <a:t>루프 C (테스트 튜닝)</a:t>
             </a:r>
             <a:endParaRPr sz="1050">
               <a:solidFill>

</xml_diff>